<commit_message>
Add time-series feature leakage audit
</commit_message>
<xml_diff>
--- a/docs/AI 预测产品线内部规划.pptx
+++ b/docs/AI 预测产品线内部规划.pptx
@@ -916,7 +916,7 @@
               <a:buNone/>
             </a:pPr>
             <a:r>
-              <a:rPr lang="en-US" sz="1800" dirty="0">
+              <a:rPr lang="en-US" sz="1800" b="1" dirty="0">
                 <a:solidFill>
                   <a:srgbClr val="111318"/>
                 </a:solidFill>
@@ -926,7 +926,7 @@
               </a:rPr>
               <a:t>SaaS </a:t>
             </a:r>
-            <a:endParaRPr lang="en-US" sz="1800" dirty="0"/>
+            <a:endParaRPr lang="en-US" sz="1800" b="1" dirty="0"/>
           </a:p>
         </p:txBody>
       </p:sp>
@@ -987,11 +987,8 @@
           </a:bodyPr>
           <a:lstStyle/>
           <a:p>
-            <a:pPr marL="0" indent="0" algn="l">
-              <a:buNone/>
-            </a:pPr>
-            <a:r>
-              <a:rPr lang="en-US" sz="900" b="1" dirty="0" err="1">
+            <a:r>
+              <a:rPr lang="zh-CN" altLang="en-US" sz="900" dirty="0">
                 <a:solidFill>
                   <a:srgbClr val="111318"/>
                 </a:solidFill>
@@ -999,21 +996,10 @@
                 <a:ea typeface="Microsoft YaHei" panose="020B0503020204020204" pitchFamily="34" charset="-122"/>
                 <a:cs typeface="Arial" pitchFamily="34" charset="-120"/>
               </a:rPr>
-              <a:t>合规要求相对低</a:t>
-            </a:r>
-            <a:r>
-              <a:rPr lang="zh-CN" altLang="en-US" sz="900" b="1" dirty="0">
-                <a:solidFill>
-                  <a:srgbClr val="111318"/>
-                </a:solidFill>
-                <a:latin typeface="Arial" pitchFamily="34" charset="0"/>
-                <a:ea typeface="Microsoft YaHei" panose="020B0503020204020204" pitchFamily="34" charset="-122"/>
-                <a:cs typeface="Arial" pitchFamily="34" charset="-120"/>
-              </a:rPr>
-              <a:t>、</a:t>
-            </a:r>
-            <a:r>
-              <a:rPr lang="en-US" sz="900" b="1" dirty="0" err="1">
+              <a:t>愿意同步数据、</a:t>
+            </a:r>
+            <a:r>
+              <a:rPr lang="en-US" sz="900" dirty="0" err="1">
                 <a:solidFill>
                   <a:srgbClr val="111318"/>
                 </a:solidFill>
@@ -1081,7 +1067,7 @@
           <a:lstStyle/>
           <a:p>
             <a:r>
-              <a:rPr lang="en-US" sz="900" b="1" dirty="0" err="1">
+              <a:rPr lang="en-US" sz="900" dirty="0" err="1">
                 <a:solidFill>
                   <a:srgbClr val="111318"/>
                 </a:solidFill>
@@ -1092,7 +1078,7 @@
               <a:t>快速上线、纯流量数据预测</a:t>
             </a:r>
             <a:r>
-              <a:rPr lang="zh-CN" altLang="en-US" sz="900" b="1" dirty="0">
+              <a:rPr lang="zh-CN" altLang="en-US" sz="900" dirty="0">
                 <a:solidFill>
                   <a:srgbClr val="111318"/>
                 </a:solidFill>
@@ -1160,7 +1146,7 @@
           <a:lstStyle/>
           <a:p>
             <a:r>
-              <a:rPr lang="en-US" sz="900" b="1" dirty="0" err="1">
+              <a:rPr lang="en-US" sz="900" dirty="0" err="1">
                 <a:solidFill>
                   <a:srgbClr val="111318"/>
                 </a:solidFill>
@@ -1233,7 +1219,7 @@
               <a:buNone/>
             </a:pPr>
             <a:r>
-              <a:rPr lang="en-US" sz="1800" dirty="0" err="1">
+              <a:rPr lang="en-US" sz="1800" b="1" dirty="0" err="1">
                 <a:solidFill>
                   <a:srgbClr val="111318"/>
                 </a:solidFill>
@@ -1243,7 +1229,7 @@
               </a:rPr>
               <a:t>本地化</a:t>
             </a:r>
-            <a:endParaRPr lang="en-US" sz="1800" dirty="0"/>
+            <a:endParaRPr lang="en-US" sz="1800" b="1" dirty="0"/>
           </a:p>
         </p:txBody>
       </p:sp>
@@ -1304,11 +1290,8 @@
           </a:bodyPr>
           <a:lstStyle/>
           <a:p>
-            <a:pPr marL="0" indent="0" algn="l">
-              <a:buNone/>
-            </a:pPr>
-            <a:r>
-              <a:rPr lang="en-US" sz="900" b="1" dirty="0" err="1">
+            <a:r>
+              <a:rPr lang="en-US" sz="900" dirty="0" err="1">
                 <a:solidFill>
                   <a:srgbClr val="111318"/>
                 </a:solidFill>
@@ -1316,10 +1299,10 @@
                 <a:ea typeface="Microsoft YaHei" panose="020B0503020204020204" pitchFamily="34" charset="-122"/>
                 <a:cs typeface="Arial" pitchFamily="34" charset="-120"/>
               </a:rPr>
-              <a:t>数据合规要求高</a:t>
-            </a:r>
-            <a:r>
-              <a:rPr lang="zh-CN" altLang="en-US" sz="900" b="1" dirty="0">
+              <a:t>数据严格不出内网</a:t>
+            </a:r>
+            <a:r>
+              <a:rPr lang="zh-CN" altLang="en-US" sz="900" dirty="0">
                 <a:solidFill>
                   <a:srgbClr val="111318"/>
                 </a:solidFill>
@@ -1330,29 +1313,7 @@
               <a:t>、</a:t>
             </a:r>
             <a:r>
-              <a:rPr lang="en-US" sz="900" b="1" dirty="0" err="1">
-                <a:solidFill>
-                  <a:srgbClr val="111318"/>
-                </a:solidFill>
-                <a:latin typeface="Arial" pitchFamily="34" charset="0"/>
-                <a:ea typeface="Microsoft YaHei" panose="020B0503020204020204" pitchFamily="34" charset="-122"/>
-                <a:cs typeface="Arial" pitchFamily="34" charset="-120"/>
-              </a:rPr>
-              <a:t>数据不出内网</a:t>
-            </a:r>
-            <a:r>
-              <a:rPr lang="zh-CN" altLang="en-US" sz="900" b="1" dirty="0">
-                <a:solidFill>
-                  <a:srgbClr val="111318"/>
-                </a:solidFill>
-                <a:latin typeface="Arial" pitchFamily="34" charset="0"/>
-                <a:ea typeface="Microsoft YaHei" panose="020B0503020204020204" pitchFamily="34" charset="-122"/>
-                <a:cs typeface="Arial" pitchFamily="34" charset="-120"/>
-              </a:rPr>
-              <a:t>、</a:t>
-            </a:r>
-            <a:r>
-              <a:rPr lang="en-US" sz="900" b="1" dirty="0" err="1">
+              <a:rPr lang="en-US" sz="900" dirty="0" err="1">
                 <a:solidFill>
                   <a:srgbClr val="111318"/>
                 </a:solidFill>
@@ -1420,7 +1381,7 @@
           <a:lstStyle/>
           <a:p>
             <a:r>
-              <a:rPr lang="en-US" sz="900" b="1" dirty="0" err="1">
+              <a:rPr lang="en-US" sz="900" dirty="0" err="1">
                 <a:solidFill>
                   <a:srgbClr val="111318"/>
                 </a:solidFill>
@@ -1431,7 +1392,7 @@
               <a:t>端到端本地化部署、高运维</a:t>
             </a:r>
             <a:r>
-              <a:rPr lang="zh-CN" altLang="en-US" sz="900" b="1" dirty="0">
+              <a:rPr lang="zh-CN" altLang="en-US" sz="900" dirty="0">
                 <a:solidFill>
                   <a:srgbClr val="111318"/>
                 </a:solidFill>
@@ -1442,7 +1403,7 @@
               <a:t>、</a:t>
             </a:r>
             <a:r>
-              <a:rPr lang="en-US" sz="900" b="1" dirty="0" err="1">
+              <a:rPr lang="en-US" sz="900" dirty="0" err="1">
                 <a:solidFill>
                   <a:srgbClr val="111318"/>
                 </a:solidFill>
@@ -1513,7 +1474,7 @@
               <a:buNone/>
             </a:pPr>
             <a:r>
-              <a:rPr lang="en-US" sz="900" b="1" dirty="0" err="1">
+              <a:rPr lang="en-US" sz="900" dirty="0" err="1">
                 <a:solidFill>
                   <a:srgbClr val="111318"/>
                 </a:solidFill>
@@ -1524,7 +1485,7 @@
               <a:t>CLI安装包、本地授权、本地推理</a:t>
             </a:r>
             <a:r>
-              <a:rPr lang="en-US" sz="900" b="1" dirty="0">
+              <a:rPr lang="en-US" sz="900" dirty="0">
                 <a:solidFill>
                   <a:srgbClr val="111318"/>
                 </a:solidFill>
@@ -1535,7 +1496,7 @@
               <a:t> </a:t>
             </a:r>
             <a:r>
-              <a:rPr lang="en-US" sz="900" b="1" dirty="0" err="1">
+              <a:rPr lang="en-US" sz="900" dirty="0" err="1">
                 <a:solidFill>
                   <a:srgbClr val="111318"/>
                 </a:solidFill>
@@ -1608,7 +1569,7 @@
               <a:buNone/>
             </a:pPr>
             <a:r>
-              <a:rPr lang="en-US" sz="1800" dirty="0">
+              <a:rPr lang="en-US" sz="1800" b="1" dirty="0">
                 <a:solidFill>
                   <a:srgbClr val="111318"/>
                 </a:solidFill>
@@ -1618,7 +1579,7 @@
               </a:rPr>
               <a:t>Agent </a:t>
             </a:r>
-            <a:endParaRPr lang="en-US" sz="1800" dirty="0"/>
+            <a:endParaRPr lang="en-US" sz="1800" b="1" dirty="0"/>
           </a:p>
         </p:txBody>
       </p:sp>
@@ -1683,7 +1644,7 @@
               <a:buNone/>
             </a:pPr>
             <a:r>
-              <a:rPr lang="en-US" sz="900" b="1" dirty="0" err="1">
+              <a:rPr lang="en-US" sz="900" dirty="0" err="1">
                 <a:solidFill>
                   <a:srgbClr val="111318"/>
                 </a:solidFill>
@@ -1694,7 +1655,7 @@
               <a:t>预算有限</a:t>
             </a:r>
             <a:r>
-              <a:rPr lang="zh-CN" altLang="en-US" sz="900" b="1" dirty="0">
+              <a:rPr lang="zh-CN" altLang="en-US" sz="900" dirty="0">
                 <a:solidFill>
                   <a:srgbClr val="111318"/>
                 </a:solidFill>
@@ -1705,7 +1666,7 @@
               <a:t>、</a:t>
             </a:r>
             <a:r>
-              <a:rPr lang="en-US" sz="900" b="1" dirty="0" err="1">
+              <a:rPr lang="en-US" sz="900" dirty="0" err="1">
                 <a:solidFill>
                   <a:srgbClr val="111318"/>
                 </a:solidFill>
@@ -1716,7 +1677,7 @@
               <a:t>低门槛验证效果</a:t>
             </a:r>
             <a:r>
-              <a:rPr lang="zh-CN" altLang="en-US" sz="900" b="1" dirty="0">
+              <a:rPr lang="zh-CN" altLang="en-US" sz="900" dirty="0">
                 <a:solidFill>
                   <a:srgbClr val="111318"/>
                 </a:solidFill>
@@ -1727,7 +1688,7 @@
               <a:t>、</a:t>
             </a:r>
             <a:r>
-              <a:rPr lang="en-US" sz="900" b="1" dirty="0" err="1">
+              <a:rPr lang="en-US" sz="900" dirty="0" err="1">
                 <a:solidFill>
                   <a:srgbClr val="111318"/>
                 </a:solidFill>
@@ -1795,7 +1756,7 @@
           <a:lstStyle/>
           <a:p>
             <a:r>
-              <a:rPr lang="en-US" sz="900" b="1" dirty="0" err="1">
+              <a:rPr lang="en-US" sz="900" dirty="0" err="1">
                 <a:solidFill>
                   <a:srgbClr val="111318"/>
                 </a:solidFill>
@@ -1806,7 +1767,7 @@
               <a:t>开箱即用、场景标准</a:t>
             </a:r>
             <a:r>
-              <a:rPr lang="zh-CN" altLang="en-US" sz="900" b="1" dirty="0">
+              <a:rPr lang="zh-CN" altLang="en-US" sz="900" dirty="0">
                 <a:solidFill>
                   <a:srgbClr val="111318"/>
                 </a:solidFill>
@@ -1817,7 +1778,7 @@
               <a:t>、</a:t>
             </a:r>
             <a:r>
-              <a:rPr lang="en-US" sz="900" b="1" dirty="0" err="1">
+              <a:rPr lang="en-US" sz="900" dirty="0" err="1">
                 <a:solidFill>
                   <a:srgbClr val="111318"/>
                 </a:solidFill>
@@ -1885,7 +1846,7 @@
           <a:lstStyle/>
           <a:p>
             <a:r>
-              <a:rPr lang="en-US" sz="900" b="1" dirty="0">
+              <a:rPr lang="en-US" sz="900" dirty="0">
                 <a:solidFill>
                   <a:srgbClr val="111318"/>
                 </a:solidFill>
@@ -1896,7 +1857,7 @@
               <a:t>CLI </a:t>
             </a:r>
             <a:r>
-              <a:rPr lang="en-US" sz="900" b="1" dirty="0" err="1">
+              <a:rPr lang="en-US" sz="900" dirty="0" err="1">
                 <a:solidFill>
                   <a:srgbClr val="111318"/>
                 </a:solidFill>
@@ -1907,7 +1868,7 @@
               <a:t>安装包</a:t>
             </a:r>
             <a:r>
-              <a:rPr lang="zh-CN" altLang="en-US" sz="900" b="1" dirty="0">
+              <a:rPr lang="zh-CN" altLang="en-US" sz="900" dirty="0">
                 <a:solidFill>
                   <a:srgbClr val="111318"/>
                 </a:solidFill>
@@ -1918,7 +1879,7 @@
               <a:t>、多模式授权、</a:t>
             </a:r>
             <a:r>
-              <a:rPr lang="en-US" sz="900" b="1" dirty="0" err="1">
+              <a:rPr lang="en-US" sz="900" dirty="0" err="1">
                 <a:solidFill>
                   <a:srgbClr val="111318"/>
                 </a:solidFill>
@@ -1929,7 +1890,7 @@
               <a:t>AutoML、流程编排</a:t>
             </a:r>
             <a:r>
-              <a:rPr lang="zh-CN" altLang="en-US" sz="900" b="1" dirty="0">
+              <a:rPr lang="zh-CN" altLang="en-US" sz="900" dirty="0">
                 <a:solidFill>
                   <a:srgbClr val="111318"/>
                 </a:solidFill>
@@ -1940,7 +1901,7 @@
               <a:t>、</a:t>
             </a:r>
             <a:r>
-              <a:rPr lang="en-US" sz="900" b="1" dirty="0" err="1">
+              <a:rPr lang="en-US" sz="900" dirty="0" err="1">
                 <a:solidFill>
                   <a:srgbClr val="111318"/>
                 </a:solidFill>
@@ -2136,7 +2097,7 @@
               <a:buNone/>
             </a:pPr>
             <a:r>
-              <a:rPr lang="en-US" sz="710" b="1" dirty="0" err="1">
+              <a:rPr lang="en-US" sz="710" dirty="0" err="1">
                 <a:solidFill>
                   <a:srgbClr val="666B73"/>
                 </a:solidFill>
@@ -2291,7 +2252,7 @@
               <a:buNone/>
             </a:pPr>
             <a:r>
-              <a:rPr lang="en-US" sz="710" b="1" dirty="0" err="1">
+              <a:rPr lang="en-US" sz="710" dirty="0" err="1">
                 <a:solidFill>
                   <a:srgbClr val="666B73"/>
                 </a:solidFill>
@@ -2446,7 +2407,7 @@
               <a:buNone/>
             </a:pPr>
             <a:r>
-              <a:rPr lang="en-US" sz="710" b="1" dirty="0">
+              <a:rPr lang="en-US" sz="710" dirty="0">
                 <a:solidFill>
                   <a:srgbClr val="666B73"/>
                 </a:solidFill>
@@ -2623,7 +2584,7 @@
               <a:buNone/>
             </a:pPr>
             <a:r>
-              <a:rPr lang="en-US" sz="710" b="1" dirty="0" err="1">
+              <a:rPr lang="en-US" sz="710" dirty="0" err="1">
                 <a:solidFill>
                   <a:srgbClr val="666B73"/>
                 </a:solidFill>
@@ -2634,7 +2595,7 @@
               <a:t>多租户、项目配置</a:t>
             </a:r>
             <a:r>
-              <a:rPr lang="zh-CN" altLang="en-US" sz="710" b="1" dirty="0">
+              <a:rPr lang="zh-CN" altLang="en-US" sz="710" dirty="0">
                 <a:solidFill>
                   <a:srgbClr val="666B73"/>
                 </a:solidFill>
@@ -2645,7 +2606,7 @@
               <a:t>、</a:t>
             </a:r>
             <a:r>
-              <a:rPr lang="en-US" sz="710" b="1" dirty="0" err="1">
+              <a:rPr lang="en-US" sz="710" dirty="0" err="1">
                 <a:solidFill>
                   <a:srgbClr val="666B73"/>
                 </a:solidFill>
@@ -2656,7 +2617,7 @@
               <a:t>在线授权、预测看板</a:t>
             </a:r>
             <a:r>
-              <a:rPr lang="zh-CN" altLang="en-US" sz="710" b="1" dirty="0">
+              <a:rPr lang="zh-CN" altLang="en-US" sz="710" dirty="0">
                 <a:solidFill>
                   <a:srgbClr val="666B73"/>
                 </a:solidFill>
@@ -2667,7 +2628,7 @@
               <a:t>、</a:t>
             </a:r>
             <a:r>
-              <a:rPr lang="en-US" sz="710" b="1" dirty="0" err="1">
+              <a:rPr lang="en-US" sz="710" dirty="0" err="1">
                 <a:solidFill>
                   <a:srgbClr val="666B73"/>
                 </a:solidFill>
@@ -2866,7 +2827,7 @@
               <a:buNone/>
             </a:pPr>
             <a:r>
-              <a:rPr lang="en-US" sz="710" b="1" dirty="0" err="1">
+              <a:rPr lang="en-US" sz="710" dirty="0" err="1">
                 <a:solidFill>
                   <a:srgbClr val="666B73"/>
                 </a:solidFill>
@@ -2877,7 +2838,7 @@
               <a:t>本地配置、CLI</a:t>
             </a:r>
             <a:r>
-              <a:rPr lang="en-US" sz="710" b="1" dirty="0">
+              <a:rPr lang="en-US" sz="710" dirty="0">
                 <a:solidFill>
                   <a:srgbClr val="666B73"/>
                 </a:solidFill>
@@ -2888,7 +2849,7 @@
               <a:t> </a:t>
             </a:r>
             <a:r>
-              <a:rPr lang="en-US" sz="710" b="1" dirty="0" err="1">
+              <a:rPr lang="en-US" sz="710" dirty="0" err="1">
                 <a:solidFill>
                   <a:srgbClr val="666B73"/>
                 </a:solidFill>
@@ -3054,7 +3015,7 @@
               <a:buNone/>
             </a:pPr>
             <a:r>
-              <a:rPr lang="en-US" sz="710" b="1" dirty="0" err="1">
+              <a:rPr lang="en-US" sz="710" dirty="0" err="1">
                 <a:solidFill>
                   <a:srgbClr val="666B73"/>
                 </a:solidFill>
@@ -3065,7 +3026,7 @@
               <a:t>AutoML、预训练模型库、流程编排、多模型融合、自动配置模板</a:t>
             </a:r>
             <a:r>
-              <a:rPr lang="zh-CN" altLang="en-US" sz="710" b="1" dirty="0">
+              <a:rPr lang="zh-CN" altLang="en-US" sz="710" dirty="0">
                 <a:solidFill>
                   <a:srgbClr val="666B73"/>
                 </a:solidFill>
@@ -3076,7 +3037,7 @@
               <a:t>、</a:t>
             </a:r>
             <a:r>
-              <a:rPr lang="en-US" altLang="zh-CN" sz="710" b="1" dirty="0">
+              <a:rPr lang="en-US" altLang="zh-CN" sz="710" dirty="0">
                 <a:solidFill>
                   <a:srgbClr val="666B73"/>
                 </a:solidFill>
@@ -3087,7 +3048,7 @@
               <a:t>C</a:t>
             </a:r>
             <a:r>
-              <a:rPr lang="en-US" sz="710" b="1" dirty="0">
+              <a:rPr lang="en-US" sz="710" dirty="0">
                 <a:solidFill>
                   <a:srgbClr val="666B73"/>
                 </a:solidFill>
@@ -3098,7 +3059,7 @@
               <a:t>LI</a:t>
             </a:r>
             <a:r>
-              <a:rPr lang="zh-CN" altLang="en-US" sz="710" b="1" dirty="0">
+              <a:rPr lang="zh-CN" altLang="en-US" sz="710" dirty="0">
                 <a:solidFill>
                   <a:srgbClr val="666B73"/>
                 </a:solidFill>
@@ -3109,7 +3070,7 @@
               <a:t> </a:t>
             </a:r>
             <a:r>
-              <a:rPr lang="en-US" altLang="zh-CN" sz="710" b="1" dirty="0">
+              <a:rPr lang="en-US" altLang="zh-CN" sz="710" dirty="0">
                 <a:solidFill>
                   <a:srgbClr val="666B73"/>
                 </a:solidFill>
@@ -3120,7 +3081,7 @@
               <a:t>+</a:t>
             </a:r>
             <a:r>
-              <a:rPr lang="zh-CN" altLang="en-US" sz="710" b="1" dirty="0">
+              <a:rPr lang="zh-CN" altLang="en-US" sz="710" dirty="0">
                 <a:solidFill>
                   <a:srgbClr val="666B73"/>
                 </a:solidFill>
@@ -3131,7 +3092,7 @@
               <a:t> </a:t>
             </a:r>
             <a:r>
-              <a:rPr lang="en-US" altLang="zh-CN" sz="710" b="1" dirty="0">
+              <a:rPr lang="en-US" altLang="zh-CN" sz="710" dirty="0">
                 <a:solidFill>
                   <a:srgbClr val="666B73"/>
                 </a:solidFill>
@@ -3142,7 +3103,7 @@
               <a:t>License </a:t>
             </a:r>
             <a:r>
-              <a:rPr lang="zh-CN" altLang="en-US" sz="710" b="1" dirty="0">
+              <a:rPr lang="zh-CN" altLang="en-US" sz="710" dirty="0">
                 <a:solidFill>
                   <a:srgbClr val="666B73"/>
                 </a:solidFill>
@@ -3349,7 +3310,7 @@
               <a:buNone/>
             </a:pPr>
             <a:r>
-              <a:rPr lang="en-US" sz="710" b="1" dirty="0" err="1">
+              <a:rPr lang="en-US" sz="710" dirty="0" err="1">
                 <a:solidFill>
                   <a:srgbClr val="666B73"/>
                 </a:solidFill>
@@ -3360,7 +3321,7 @@
               <a:t>成本计量、监控告警、漂移检测、重训策略、SLA</a:t>
             </a:r>
             <a:r>
-              <a:rPr lang="en-US" sz="710" b="1" dirty="0">
+              <a:rPr lang="en-US" sz="710" dirty="0">
                 <a:solidFill>
                   <a:srgbClr val="666B73"/>
                 </a:solidFill>
@@ -3371,7 +3332,7 @@
               <a:t> </a:t>
             </a:r>
             <a:r>
-              <a:rPr lang="en-US" sz="710" b="1" dirty="0" err="1">
+              <a:rPr lang="en-US" sz="710" dirty="0" err="1">
                 <a:solidFill>
                   <a:srgbClr val="666B73"/>
                 </a:solidFill>
@@ -3382,7 +3343,7 @@
               <a:t>与运维</a:t>
             </a:r>
             <a:r>
-              <a:rPr lang="zh-CN" altLang="en-US" sz="710" b="1" dirty="0">
+              <a:rPr lang="zh-CN" altLang="en-US" sz="710" dirty="0">
                 <a:solidFill>
                   <a:srgbClr val="666B73"/>
                 </a:solidFill>

</xml_diff>